<commit_message>
ws02 Lab 1·2 표기 정정 + class5.pptx 추가
Lab 1 (Slot 4) — nb00 워밍업 → 수동 공격·방어
- index.html 카드 제목: "수동 공격 → Garak..." → "수동 공격·방어 → Garak..."
- 활동 W → M, 부연에 방어 레이어 직접 구현 (입력 검증 · 출력 필터 · 권한 분리) 명시
- Colab 버튼: "nb00 워밍업" → "nb00 수동 공격·방어"

Lab 2 (Slot 5) — 슬라이드 파일명 통일
- 신규 deck: ws02_slide_class5.pptx (RAG · VectorDB · 20슬라이드)
- index.html Lab 2 카드 슬라이드 링크: ws02_Lab2_RAG_VectorDB.pptx → ws02_slide_class5.pptx
- 옛 ws02_Lab2_RAG_VectorDB.pptx · ws02_handout_slot2.pptx · security_slides.pptx 정리

이로써 5개 슬롯 슬라이드 모두 ws02_slide_class{N}.pptx 형식 통일:
class1 (NIS·KISA) / class2 (OWASP) / class3 (Defense+Gandalf) / class4 (Lab1 Garak) / class5 (Lab2 RAG)

기타: slide_update_todo.md 정리 후 archives/ 로 이동 (적용 완료),
ws02_slide_inserts.pptx 신규 4장 (TODO 1.1/1.2/4.1/4.2) 도 archives/

Co-Authored-By: Claude Opus 4.7 <noreply@anthropic.com>
</commit_message>
<xml_diff>
--- a/ws02/class/ws02_slide_class1.pptx
+++ b/ws02/class/ws02_slide_class1.pptx
@@ -6554,49 +6554,330 @@
           <a:lstStyle/>
           <a:p>
             <a:r>
-              <a:t>⏱️  0:52 · 3.5분</a:t>
-            </a:r>
-          </a:p>
-          <a:p>
-            <a:r>
-              <a:t>★ KEEP — 절대 빠뜨리지 말 것</a:t>
-            </a:r>
-          </a:p>
-          <a:p>
-            <a:endParaRPr/>
-          </a:p>
-          <a:p>
-            <a:r>
-              <a:t>🎤 강사 멘트:</a:t>
-            </a:r>
-          </a:p>
-          <a:p>
-            <a:r>
-              <a:t>이 한 장만 외워도 절반은 끝난 겁니다. 두 문서를 같이 써야 완전한 보안 체계가 됩니다.</a:t>
-            </a:r>
-          </a:p>
-          <a:p>
-            <a:endParaRPr/>
-          </a:p>
-          <a:p>
-            <a:r>
-              <a:t>핵심 포인트:</a:t>
-            </a:r>
-          </a:p>
-          <a:p>
-            <a:r>
-              <a:t>  • NIS — 위협·대책 중심 / T-M 거울 구조 / 4 레이어 / 보안 체크리스트</a:t>
-            </a:r>
-          </a:p>
-          <a:p>
-            <a:r>
-              <a:t>  • KISA — 역할·책임 중심 / 3역할 / 생명주기별 / 거버넌스 설계</a:t>
-            </a:r>
-          </a:p>
-          <a:p>
-            <a:r>
-              <a:t>  • 결론: NIS 로 무엇을 막을지 식별 → KISA 로 누가 언제 실행할지 배정</a:t>
-            </a:r>
+              <a:t>이</a:t>
+            </a:r>
+            <a:r>
+              <a:rPr dirty="0"/>
+              <a:t> </a:t>
+            </a:r>
+            <a:r>
+              <a:rPr dirty="0" err="1"/>
+              <a:t>한</a:t>
+            </a:r>
+            <a:r>
+              <a:rPr dirty="0"/>
+              <a:t> </a:t>
+            </a:r>
+            <a:r>
+              <a:rPr dirty="0" err="1"/>
+              <a:t>장만</a:t>
+            </a:r>
+            <a:r>
+              <a:rPr dirty="0"/>
+              <a:t> </a:t>
+            </a:r>
+            <a:r>
+              <a:rPr dirty="0" err="1"/>
+              <a:t>외워도</a:t>
+            </a:r>
+            <a:r>
+              <a:rPr dirty="0"/>
+              <a:t> </a:t>
+            </a:r>
+            <a:r>
+              <a:rPr dirty="0" err="1"/>
+              <a:t>절반은</a:t>
+            </a:r>
+            <a:r>
+              <a:rPr dirty="0"/>
+              <a:t> </a:t>
+            </a:r>
+            <a:r>
+              <a:rPr dirty="0" err="1"/>
+              <a:t>끝난</a:t>
+            </a:r>
+            <a:r>
+              <a:rPr dirty="0"/>
+              <a:t> </a:t>
+            </a:r>
+            <a:r>
+              <a:rPr dirty="0" err="1"/>
+              <a:t>겁니다</a:t>
+            </a:r>
+            <a:r>
+              <a:rPr dirty="0"/>
+              <a:t>. </a:t>
+            </a:r>
+            <a:r>
+              <a:rPr dirty="0" err="1"/>
+              <a:t>두</a:t>
+            </a:r>
+            <a:r>
+              <a:rPr dirty="0"/>
+              <a:t> </a:t>
+            </a:r>
+            <a:r>
+              <a:rPr dirty="0" err="1"/>
+              <a:t>문서를</a:t>
+            </a:r>
+            <a:r>
+              <a:rPr dirty="0"/>
+              <a:t> </a:t>
+            </a:r>
+            <a:r>
+              <a:rPr dirty="0" err="1"/>
+              <a:t>같이</a:t>
+            </a:r>
+            <a:r>
+              <a:rPr dirty="0"/>
+              <a:t> </a:t>
+            </a:r>
+            <a:r>
+              <a:rPr dirty="0" err="1"/>
+              <a:t>써야</a:t>
+            </a:r>
+            <a:r>
+              <a:rPr dirty="0"/>
+              <a:t> </a:t>
+            </a:r>
+            <a:r>
+              <a:rPr dirty="0" err="1"/>
+              <a:t>완전한</a:t>
+            </a:r>
+            <a:r>
+              <a:rPr dirty="0"/>
+              <a:t> </a:t>
+            </a:r>
+            <a:r>
+              <a:rPr dirty="0" err="1"/>
+              <a:t>보안</a:t>
+            </a:r>
+            <a:r>
+              <a:rPr dirty="0"/>
+              <a:t> </a:t>
+            </a:r>
+            <a:r>
+              <a:rPr dirty="0" err="1"/>
+              <a:t>체계가</a:t>
+            </a:r>
+            <a:r>
+              <a:rPr dirty="0"/>
+              <a:t> </a:t>
+            </a:r>
+            <a:r>
+              <a:rPr dirty="0" err="1"/>
+              <a:t>됩니다</a:t>
+            </a:r>
+            <a:r>
+              <a:rPr dirty="0"/>
+              <a:t>.</a:t>
+            </a:r>
+          </a:p>
+          <a:p>
+            <a:endParaRPr dirty="0"/>
+          </a:p>
+          <a:p>
+            <a:r>
+              <a:rPr dirty="0" err="1"/>
+              <a:t>핵심</a:t>
+            </a:r>
+            <a:r>
+              <a:rPr dirty="0"/>
+              <a:t> </a:t>
+            </a:r>
+            <a:r>
+              <a:rPr dirty="0" err="1"/>
+              <a:t>포인트</a:t>
+            </a:r>
+            <a:r>
+              <a:rPr dirty="0"/>
+              <a:t>:</a:t>
+            </a:r>
+          </a:p>
+          <a:p>
+            <a:r>
+              <a:rPr dirty="0"/>
+              <a:t>  • NIS — </a:t>
+            </a:r>
+            <a:r>
+              <a:rPr dirty="0" err="1"/>
+              <a:t>위협·대책</a:t>
+            </a:r>
+            <a:r>
+              <a:rPr dirty="0"/>
+              <a:t> </a:t>
+            </a:r>
+            <a:r>
+              <a:rPr dirty="0" err="1"/>
+              <a:t>중심</a:t>
+            </a:r>
+            <a:r>
+              <a:rPr dirty="0"/>
+              <a:t> / T-M </a:t>
+            </a:r>
+            <a:r>
+              <a:rPr dirty="0" err="1"/>
+              <a:t>거울</a:t>
+            </a:r>
+            <a:r>
+              <a:rPr dirty="0"/>
+              <a:t> </a:t>
+            </a:r>
+            <a:r>
+              <a:rPr dirty="0" err="1"/>
+              <a:t>구조</a:t>
+            </a:r>
+            <a:r>
+              <a:rPr dirty="0"/>
+              <a:t> / 4 </a:t>
+            </a:r>
+            <a:r>
+              <a:rPr dirty="0" err="1"/>
+              <a:t>레이어</a:t>
+            </a:r>
+            <a:r>
+              <a:rPr dirty="0"/>
+              <a:t> / </a:t>
+            </a:r>
+            <a:r>
+              <a:rPr dirty="0" err="1"/>
+              <a:t>보안</a:t>
+            </a:r>
+            <a:r>
+              <a:rPr dirty="0"/>
+              <a:t> </a:t>
+            </a:r>
+            <a:r>
+              <a:rPr dirty="0" err="1"/>
+              <a:t>체크리스트</a:t>
+            </a:r>
+            <a:endParaRPr dirty="0"/>
+          </a:p>
+          <a:p>
+            <a:r>
+              <a:rPr dirty="0"/>
+              <a:t>  • KISA — </a:t>
+            </a:r>
+            <a:r>
+              <a:rPr dirty="0" err="1"/>
+              <a:t>역할·책임</a:t>
+            </a:r>
+            <a:r>
+              <a:rPr dirty="0"/>
+              <a:t> </a:t>
+            </a:r>
+            <a:r>
+              <a:rPr dirty="0" err="1"/>
+              <a:t>중심</a:t>
+            </a:r>
+            <a:r>
+              <a:rPr dirty="0"/>
+              <a:t> / 3역할 / </a:t>
+            </a:r>
+            <a:r>
+              <a:rPr dirty="0" err="1"/>
+              <a:t>생명주기별</a:t>
+            </a:r>
+            <a:r>
+              <a:rPr dirty="0"/>
+              <a:t> / </a:t>
+            </a:r>
+            <a:r>
+              <a:rPr dirty="0" err="1"/>
+              <a:t>거버넌스</a:t>
+            </a:r>
+            <a:r>
+              <a:rPr dirty="0"/>
+              <a:t> </a:t>
+            </a:r>
+            <a:r>
+              <a:rPr dirty="0" err="1"/>
+              <a:t>설계</a:t>
+            </a:r>
+            <a:endParaRPr dirty="0"/>
+          </a:p>
+          <a:p>
+            <a:r>
+              <a:rPr dirty="0"/>
+              <a:t>  • </a:t>
+            </a:r>
+            <a:r>
+              <a:rPr dirty="0" err="1"/>
+              <a:t>결론</a:t>
+            </a:r>
+            <a:r>
+              <a:rPr dirty="0"/>
+              <a:t>: NIS </a:t>
+            </a:r>
+            <a:r>
+              <a:rPr dirty="0" err="1"/>
+              <a:t>로</a:t>
+            </a:r>
+            <a:r>
+              <a:rPr dirty="0"/>
+              <a:t> </a:t>
+            </a:r>
+            <a:r>
+              <a:rPr dirty="0" err="1"/>
+              <a:t>무엇을</a:t>
+            </a:r>
+            <a:r>
+              <a:rPr dirty="0"/>
+              <a:t> </a:t>
+            </a:r>
+            <a:r>
+              <a:rPr dirty="0" err="1"/>
+              <a:t>막을지</a:t>
+            </a:r>
+            <a:r>
+              <a:rPr dirty="0"/>
+              <a:t> </a:t>
+            </a:r>
+            <a:r>
+              <a:rPr dirty="0" err="1"/>
+              <a:t>식별</a:t>
+            </a:r>
+            <a:r>
+              <a:rPr dirty="0"/>
+              <a:t> → KISA </a:t>
+            </a:r>
+            <a:r>
+              <a:rPr dirty="0" err="1"/>
+              <a:t>로</a:t>
+            </a:r>
+            <a:r>
+              <a:rPr dirty="0"/>
+              <a:t> </a:t>
+            </a:r>
+            <a:r>
+              <a:rPr dirty="0" err="1"/>
+              <a:t>누가</a:t>
+            </a:r>
+            <a:r>
+              <a:rPr dirty="0"/>
+              <a:t> </a:t>
+            </a:r>
+            <a:r>
+              <a:rPr dirty="0" err="1"/>
+              <a:t>언제</a:t>
+            </a:r>
+            <a:r>
+              <a:rPr dirty="0"/>
+              <a:t> </a:t>
+            </a:r>
+            <a:r>
+              <a:rPr dirty="0" err="1"/>
+              <a:t>실행할지</a:t>
+            </a:r>
+            <a:r>
+              <a:rPr dirty="0"/>
+              <a:t> </a:t>
+            </a:r>
+            <a:r>
+              <a:rPr dirty="0" err="1"/>
+              <a:t>배정</a:t>
+            </a:r>
+            <a:endParaRPr dirty="0"/>
           </a:p>
         </p:txBody>
       </p:sp>

</xml_diff>